<commit_message>
docs(pitch): the finals deck rebuilt with 2172 tests and runtimes v54
Co-Authored-By: Claude Opus 5.5 <noreply@anthropic.com>
</commit_message>
<xml_diff>
--- a/docs/pitch/TheAgentOrg-hackathon-finals.pptx
+++ b/docs/pitch/TheAgentOrg-hackathon-finals.pptx
@@ -21233,7 +21233,7 @@
                 </a:solidFill>
                 <a:latin typeface="Helvetica Neue"/>
               </a:rPr>
-              <a:t>2171</a:t>
+              <a:t>2172</a:t>
             </a:r>
           </a:p>
         </p:txBody>
@@ -21421,7 +21421,7 @@
                 </a:solidFill>
                 <a:latin typeface="Helvetica Neue"/>
               </a:rPr>
-              <a:t>v52</a:t>
+              <a:t>v54</a:t>
             </a:r>
           </a:p>
         </p:txBody>

</xml_diff>

<commit_message>
docs(pitch): mirror the re-verified finals deck, notes and handout
Co-Authored-By: Claude Opus 5.5 <noreply@anthropic.com>
</commit_message>
<xml_diff>
--- a/docs/pitch/TheAgentOrg-hackathon-finals.pptx
+++ b/docs/pitch/TheAgentOrg-hackathon-finals.pptx
@@ -588,7 +588,13 @@
           <a:lstStyle/>
           <a:p>
             <a:r>
-              <a:t>SAY None of this is our wording. GitHub Copilot's review "will not block merging changes". Anthropic's code review "always completes with a neutral conclusion so it never blocks". OpenAI's Codex guidance says it doesn't "replace tests, branch protections, or required approvals". Cursor's findings default to neutral. And Snyk's own page puts our thesis in six words: the generator cannot be the validator.</a:t>
+              <a:t>SAY None of this is our wording. GitHub Copilot's review leaves, by default, "a Comment review, not a Request changes review", so it never blocks. Anthropic's code review "always completes with a neutral conclusion so it never blocks merging". OpenAI's Codex guidance says it doesn't "replace tests, branch protections, or required approvals". Cursor's findings "default to neutral". And Snyk's own page puts our thesis in six words: the generator cannot be the validator.</a:t>
+            </a:r>
+          </a:p>
+          <a:p/>
+          <a:p>
+            <a:r>
+              <a:t>IF ASKED — "can't Copilot approve pull requests now?" Yes, if a team turns that on. That lets the model pass a change; it still cannot block one. It makes our point sharper, not weaker.</a:t>
             </a:r>
           </a:p>
           <a:p/>
@@ -670,7 +676,7 @@
           <a:lstStyle/>
           <a:p>
             <a:r>
-              <a:t>SAY This is the argument for the whole design. With Cursor's hooks, if the hook itself fails, the action goes ahead; their documentation calls it fail-open by default. With Claude Code's hooks, only one specific failure blocks; any other lets the action through, and a mistyped path silently disables the gate. And if Semgrep crashes, it reports success. A check that did not run, reading as a check that passed. That is exactly what we refuse: in our pipeline, a missing or crashed scanner blocks the change.</a:t>
+              <a:t>SAY This is the argument for the whole design. With Cursor's hooks, if the hook itself fails, the action goes ahead; their documentation calls it fail-open by default. With Claude Code's hooks, only one specific failure blocks; any other lets the action through, and in their words, "a mistyped path in settings.json leaves the gate silently disabled". And by default, if Semgrep crashes, it still reports success. A check that did not run, reading as a check that passed. That is exactly what we refuse: in our pipeline, a missing or crashed scanner blocks the change.</a:t>
             </a:r>
           </a:p>
         </p:txBody>
@@ -740,7 +746,7 @@
           <a:lstStyle/>
           <a:p>
             <a:r>
-              <a:t>SAY Two thousand one hundred and seventy-two automated tests across ninety-three files, plus three hundred and eleven for the web app. Five agent runtimes, all ready on the same version; a split would mean a half-finished deploy, and we check for it before every demo. It runs in the cloud from a real issue. It is a product, not a script: you sign in, pick a repository, start a run, watch each stage, approve a gate and read what it cost. And it is multi-tenant: each customer's data sits in its own partition, and AWS itself refuses a read of anyone else's, so our code does not have to remember to.</a:t>
+              <a:t>SAY Two thousand one hundred and seventy-two automated tests across ninety-three files, plus three hundred and thirty-four for the web app. Five agent runtimes, all ready on the same version; a split would mean a half-finished deploy, and we check for it before every demo. It runs in the cloud from a real issue. It is a product, not a script: you sign in, pick a repository, start a run, watch each stage, approve a gate and read what it cost. And it is multi-tenant: each customer's data sits in its own partition, and AWS itself refuses a read of anyone else's, so our code does not have to remember to.</a:t>
             </a:r>
           </a:p>
         </p:txBody>
@@ -1318,7 +1324,7 @@
           <a:p/>
           <a:p>
             <a:r>
-              <a:t>IF ASKED — "isn't this what branch protection is for?" Branch protection enforces a status check, and every AI reviewer in our research reports a neutral status: it never fails the check. We come back to that on the differentiation slide.</a:t>
+              <a:t>IF ASKED — "isn't this what branch protection is for?" Branch protection enforces what it is told to. The AI reviewers we checked leave a comment or report a neutral status by default, so requiring them does not stop a merge. We come back to that on the differentiation slide.</a:t>
             </a:r>
           </a:p>
         </p:txBody>
@@ -1458,7 +1464,13 @@
           <a:lstStyle/>
           <a:p>
             <a:r>
-              <a:t>SAY Every agent here is a language model, and any of them can be wrong. So the component that stops a change is deliberately not one of them. Compare the two columns. The reviewer is a model reading the change. It catches intent, logic and a plan mismatch, and it is advisory: when it objects, the change goes back to the developer, but it cannot stop the run. The security stage is three scanners and a fixed rule. Same input, same answer, every time, and there is no model in it, so there is nothing to argue with.</a:t>
+              <a:t>SAY Every agent here is a language model, and any of them can be wrong. So the component that stops a change is deliberately not one of them. Compare the two columns. The reviewer is a model reading the change. It catches intent, logic and a plan mismatch, and it is advisory: when it objects, the change goes back to the developer, but it cannot stop the run. The security stage is three scanners and a fixed rule. Same input, same answer, every time, and no model takes part in the decision, so there is nothing to argue with.</a:t>
+            </a:r>
+          </a:p>
+          <a:p/>
+          <a:p>
+            <a:r>
+              <a:t>IF ASKED — "but the security agent calls a model?" Only to write the sentence that explains the verdict, after the verdict is decided. That text cannot change it.</a:t>
             </a:r>
           </a:p>
           <a:p/>
@@ -1622,19 +1634,31 @@
           <a:lstStyle/>
           <a:p>
             <a:r>
-              <a:t>SAY Follow the numbers. One: an engineer opens an issue, or starts a run from our app. Two: GitHub sends a signed webhook to a Lambda function, which checks the signature before anything else happens and hands the event to EventBridge. Three: a rule matches new issues and starts the pipeline; if that fails, the event waits in an SQS dead-letter queue. The pipeline is seven GitHub Actions jobs. Four: each job takes an AWS role through OIDC, so there is no stored AWS key anywhere, and calls that agent's Bedrock AgentCore runtime. Five: the agents call Amazon Nova 2 Lite. Six: the security stage is three scanners and a fixed threshold, with no model in it. Seven: the gates wait for a named person, in GitHub or in our app. Eight: the app, on Amplify with Cognito sign-in, reads each run from DynamoDB through a role that can only see its own tenant's data.</a:t>
+              <a:t>SAY Follow the numbers. One: an engineer opens an issue, or starts a run from our app. Two: GitHub sends a signed webhook to a Lambda function, which checks the signature before anything else happens and hands the event to EventBridge. Three: a rule matches new issues and starts the pipeline; if that fails, the event waits in an SQS dead-letter queue. The pipeline is seven GitHub Actions jobs. Four: each agent job takes an AWS role through OIDC, so there is no stored AWS key anywhere, and calls its agent on Bedrock AgentCore: planner, developer, reviewer, security, SRE. Five: the agents call Amazon Nova 2 Lite. Six: the security stage decides with three scanners and a fixed threshold, no model; the model only writes the explanation afterwards. Seven: the gates wait for a named person, in GitHub or in our app. Eight: the app, on Amplify, reads each run from DynamoDB through a role that can only see its own tenant's data.</a:t>
             </a:r>
           </a:p>
           <a:p/>
           <a:p>
             <a:r>
+              <a:t>IF ASKED — "the security agent calls the model too?" Yes, for one thing: the sentence explaining the verdict. The verdict is computed first, by the scanners and the threshold, and the model's text goes into a separate field that cannot change it. Take the model away and the block still happens.</a:t>
+            </a:r>
+          </a:p>
+          <a:p/>
+          <a:p>
+            <a:r>
               <a:t>IF ASKED — "why AgentCore and not just Lambda?" Each agent is an isolated runtime with its own identity and logs, and the security image is the only one carrying the three scanners. Isolation is the point.</a:t>
             </a:r>
           </a:p>
           <a:p/>
           <a:p>
             <a:r>
-              <a:t>IF ASKED — "where is a run's state kept?" It is passed from job to job by GitHub Actions, and every stage writes a copy to DynamoDB, which is what the app reads.</a:t>
+              <a:t>IF ASKED — "where is a run's state kept?" It is passed from job to job by GitHub Actions. The four jobs that hold an AWS role (plan, develop, SRE and promote) write a copy to DynamoDB, which is what the app reads. The gates hold no AWS credentials on purpose, so a gate's decision reaches DynamoDB with the next job.</a:t>
+            </a:r>
+          </a:p>
+          <a:p/>
+          <a:p>
+            <a:r>
+              <a:t>IF ASKED — "how do people sign in?" Email through Amazon Cognito, or GitHub.</a:t>
             </a:r>
           </a:p>
         </p:txBody>
@@ -1704,13 +1728,13 @@
           <a:lstStyle/>
           <a:p>
             <a:r>
-              <a:t>SAY A change costs between one point three and one point seven cents of model time, measured over three clean runs and priced from the AWS Pricing API. The model is 99.9 percent of that. Lambda, EventBridge and DynamoDB together came to twelve millionths of a dollar, which is why the only cost work worth doing is prompt caching. The median time from ticket to merge is five point four minutes, and none of the eight merged changes carried a credential.</a:t>
+              <a:t>SAY A change costs between one point three and one point seven cents of model time, measured over three clean runs and priced from the AWS Pricing API. The model is 99.9 percent of that. Lambda, EventBridge and DynamoDB together came to twelve millionths of a dollar, which is why the only cost work worth doing is prompt caching. The median time from ticket to merge is just under eight minutes, and none of the twelve merged changes carried a credential.</a:t>
             </a:r>
           </a:p>
           <a:p/>
           <a:p>
             <a:r>
-              <a:t>SAY THE CAVEAT — do not wait to be asked. Eight of thirty-seven runs merged, so the median covers the runs that finished. And the zero is a real result: the same scan finds three credentials in an unmerged pull request, so it is not a scan that finds nothing.</a:t>
+              <a:t>SAY THE CAVEAT — do not wait to be asked. Twelve of fifty-seven runs merged, so the median covers the runs that finished, and a person clicked every gate in it. And the zero is a real result: the same scan finds three credentials in an unmerged pull request, so it is not a scan that finds nothing.</a:t>
             </a:r>
           </a:p>
           <a:p/>
@@ -5447,7 +5471,7 @@
                 </a:solidFill>
                 <a:latin typeface="Helvetica Neue"/>
               </a:rPr>
-              <a:t>“will not block merging changes”</a:t>
+              <a:t>by default “a ‘Comment’ review, not … a ‘Request changes’ review”</a:t>
             </a:r>
           </a:p>
         </p:txBody>
@@ -5525,7 +5549,7 @@
                 </a:solidFill>
                 <a:latin typeface="Helvetica Neue"/>
               </a:rPr>
-              <a:t>“always completes with a neutral conclusion so it never blocks”</a:t>
+              <a:t>“always completes with a neutral conclusion so it never blocks merging”</a:t>
             </a:r>
           </a:p>
         </p:txBody>
@@ -6117,7 +6141,7 @@
         <p:spPr>
           <a:xfrm>
             <a:off x="1005840" y="2240280"/>
-            <a:ext cx="3224784" cy="2011680"/>
+            <a:ext cx="3224784" cy="2331720"/>
           </a:xfrm>
           <a:prstGeom prst="rect">
             <a:avLst/>
@@ -6202,7 +6226,7 @@
         <p:spPr>
           <a:xfrm>
             <a:off x="1188720" y="2916936"/>
-            <a:ext cx="2859024" cy="1188720"/>
+            <a:ext cx="2859024" cy="1508760"/>
           </a:xfrm>
           <a:prstGeom prst="rect">
             <a:avLst/>
@@ -6241,7 +6265,7 @@
         <p:spPr>
           <a:xfrm>
             <a:off x="4468368" y="2240280"/>
-            <a:ext cx="3224784" cy="2011680"/>
+            <a:ext cx="3224784" cy="2331720"/>
           </a:xfrm>
           <a:prstGeom prst="rect">
             <a:avLst/>
@@ -6326,7 +6350,7 @@
         <p:spPr>
           <a:xfrm>
             <a:off x="4651248" y="2916936"/>
-            <a:ext cx="2859024" cy="1188720"/>
+            <a:ext cx="2859024" cy="1508760"/>
           </a:xfrm>
           <a:prstGeom prst="rect">
             <a:avLst/>
@@ -6351,7 +6375,7 @@
                 </a:solidFill>
                 <a:latin typeface="Helvetica Neue"/>
               </a:rPr>
-              <a:t>Only one specific failure blocks; any other lets the action through, and “a mistyped path silently disables the gate”.</a:t>
+              <a:t>Only one specific failure blocks; any other lets the action through. Their documentation: “a mistyped path in settings.json leaves the gate silently disabled”.</a:t>
             </a:r>
           </a:p>
         </p:txBody>
@@ -6365,7 +6389,7 @@
         <p:spPr>
           <a:xfrm>
             <a:off x="7930896" y="2240280"/>
-            <a:ext cx="3224784" cy="2011680"/>
+            <a:ext cx="3224784" cy="2331720"/>
           </a:xfrm>
           <a:prstGeom prst="rect">
             <a:avLst/>
@@ -6450,7 +6474,7 @@
         <p:spPr>
           <a:xfrm>
             <a:off x="8113776" y="2916936"/>
-            <a:ext cx="2859024" cy="1188720"/>
+            <a:ext cx="2859024" cy="1508760"/>
           </a:xfrm>
           <a:prstGeom prst="rect">
             <a:avLst/>
@@ -6475,7 +6499,7 @@
                 </a:solidFill>
                 <a:latin typeface="Helvetica Neue"/>
               </a:rPr>
-              <a:t>If the scanner crashes, it reports success. A crash looks exactly like a clean scan.</a:t>
+              <a:t>By default, if the scanner crashes it still reports success, so a crash reads like a clean scan.</a:t>
             </a:r>
           </a:p>
         </p:txBody>
@@ -7393,7 +7417,7 @@
                 </a:solidFill>
                 <a:latin typeface="Helvetica Neue"/>
               </a:rPr>
-              <a:t>311</a:t>
+              <a:t>334</a:t>
             </a:r>
           </a:p>
         </p:txBody>
@@ -7448,7 +7472,7 @@
                 </a:solidFill>
                 <a:latin typeface="Helvetica Neue"/>
               </a:rPr>
-              <a:t>across 24 files</a:t>
+              <a:t>across 26 files</a:t>
             </a:r>
           </a:p>
         </p:txBody>
@@ -9339,7 +9363,7 @@
                 </a:solidFill>
                 <a:latin typeface="Helvetica Neue"/>
               </a:rPr>
-              <a:t>one compose file runs the database, the API and the web app</a:t>
+              <a:t>one compose file runs the web app, the API, the worker and a local model</a:t>
             </a:r>
           </a:p>
         </p:txBody>
@@ -22244,7 +22268,7 @@
                 </a:solidFill>
                 <a:latin typeface="Helvetica Neue"/>
               </a:rPr>
-              <a:t>no, there is no model in it</a:t>
+              <a:t>no, no model takes part in the decision</a:t>
             </a:r>
           </a:p>
         </p:txBody>
@@ -23891,7 +23915,7 @@
                 </a:solidFill>
                 <a:latin typeface="Helvetica Neue"/>
               </a:rPr>
-              <a:t>5.39 min</a:t>
+              <a:t>7.88 min</a:t>
             </a:r>
           </a:p>
         </p:txBody>
@@ -23946,7 +23970,7 @@
                 </a:solidFill>
                 <a:latin typeface="Helvetica Neue"/>
               </a:rPr>
-              <a:t>8 merges</a:t>
+              <a:t>12 merges</a:t>
             </a:r>
           </a:p>
         </p:txBody>
@@ -23985,7 +24009,7 @@
                 </a:solidFill>
                 <a:latin typeface="Helvetica Neue"/>
               </a:rPr>
-              <a:t>0 of 8</a:t>
+              <a:t>0 of 12</a:t>
             </a:r>
           </a:p>
         </p:txBody>
@@ -24157,7 +24181,7 @@
                 </a:solidFill>
                 <a:latin typeface="Helvetica Neue"/>
               </a:rPr>
-              <a:t>8 of 37 runs merged, so the median covers the runs that finished. The same scan finds 3 credentials in unmerged pull request #50, so the zero is a real result.</a:t>
+              <a:t>12 of 57 runs merged, so the median covers the runs that finished. The same scan finds 3 credentials in unmerged pull request #72, so the zero is a real result.</a:t>
             </a:r>
           </a:p>
         </p:txBody>

</xml_diff>

<commit_message>
docs(pitch): mirror the finals deck at v55
Co-Authored-By: Claude Opus 5.5 <noreply@anthropic.com>
</commit_message>
<xml_diff>
--- a/docs/pitch/TheAgentOrg-hackathon-finals.pptx
+++ b/docs/pitch/TheAgentOrg-hackathon-finals.pptx
@@ -746,7 +746,7 @@
           <a:lstStyle/>
           <a:p>
             <a:r>
-              <a:t>SAY Two thousand one hundred and seventy-two automated tests across ninety-three files, plus three hundred and thirty-four for the web app. Five agent runtimes, all ready on the same version; a split would mean a half-finished deploy, and we check for it before every demo. It runs in the cloud from a real issue. It is a product, not a script: you sign in, pick a repository, start a run, watch each stage, approve a gate and read what it cost. And it is multi-tenant: each customer's data sits in its own partition, and AWS itself refuses a read of anyone else's, so our code does not have to remember to.</a:t>
+              <a:t>SAY Two thousand one hundred and seventy-six automated tests across ninety-five files, plus three hundred and thirty-eight for the web app. Five agent runtimes, all ready on the same version; a split would mean a half-finished deploy, and we check for it before every demo. It runs in the cloud from a real issue. It is a product, not a script: you sign in, pick a repository, start a run, watch each stage, approve a gate and read what it cost. And it is multi-tenant: each customer's data sits in its own partition, and AWS itself refuses a read of anyone else's, so our code does not have to remember to.</a:t>
             </a:r>
           </a:p>
         </p:txBody>
@@ -7323,7 +7323,7 @@
                 </a:solidFill>
                 <a:latin typeface="Helvetica Neue"/>
               </a:rPr>
-              <a:t>2172</a:t>
+              <a:t>2176</a:t>
             </a:r>
           </a:p>
         </p:txBody>
@@ -7378,7 +7378,7 @@
                 </a:solidFill>
                 <a:latin typeface="Helvetica Neue"/>
               </a:rPr>
-              <a:t>across 93 files</a:t>
+              <a:t>across 95 files</a:t>
             </a:r>
           </a:p>
         </p:txBody>
@@ -7417,7 +7417,7 @@
                 </a:solidFill>
                 <a:latin typeface="Helvetica Neue"/>
               </a:rPr>
-              <a:t>334</a:t>
+              <a:t>338</a:t>
             </a:r>
           </a:p>
         </p:txBody>
@@ -7511,7 +7511,7 @@
                 </a:solidFill>
                 <a:latin typeface="Helvetica Neue"/>
               </a:rPr>
-              <a:t>v54</a:t>
+              <a:t>v55</a:t>
             </a:r>
           </a:p>
         </p:txBody>

</xml_diff>

<commit_message>
docs: the finals demo is a real ticket, verified in the cloud on run #73; mirror the pitch
Co-Authored-By: Claude Opus 5.5 <noreply@anthropic.com>
</commit_message>
<xml_diff>
--- a/docs/pitch/TheAgentOrg-hackathon-finals.pptx
+++ b/docs/pitch/TheAgentOrg-hackathon-finals.pptx
@@ -1032,13 +1032,25 @@
           <a:lstStyle/>
           <a:p>
             <a:r>
-              <a:t>SAY Let me show you the half that matters: a ticket that deliberately carries a credential. Watch the line numbers when it blocks.</a:t>
+              <a:t>SAY Let me show you the half that matters. This ticket asks for something that looks reasonable: pin an old version of the requests library for a legacy proxy. Nothing is planted and no demo flag is set. Watch what the reviewer says, and what the scanners say.</a:t>
             </a:r>
           </a:p>
           <a:p/>
           <a:p>
             <a:r>
-              <a:t>IF ASKED — "what are the three cards?" One per scanner, each showing its own worst finding against the threshold. Only gitleaks reached it, so only gitleaks blocks. That comparison is the whole decision, and a run that passes shows it too.</a:t>
+              <a:t>IF ASKED — "what are the three cards?" One per scanner, each showing its own worst finding against the threshold. Only Trivy reached it, with a high-severity CVE; the medium ones stay below the line. That comparison is the whole decision.</a:t>
+            </a:r>
+          </a:p>
+          <a:p/>
+          <a:p>
+            <a:r>
+              <a:t>IF ASKED — "the explanation under the verdict is wrong" It can be: that paragraph is written by the model after the verdict, and it has no say in it. That is exactly why the model does not decide.</a:t>
+            </a:r>
+          </a:p>
+          <a:p/>
+          <a:p>
+            <a:r>
+              <a:t>IF ASKED — "why does the page say a stage used a canned answer?" The agent that writes tests from the ticket did not get an answer from the model this time, so it used its built-in stand-in, and the page says so rather than hiding it. It does not affect the block.</a:t>
             </a:r>
           </a:p>
         </p:txBody>
@@ -13450,7 +13462,7 @@
                 </a:solidFill>
                 <a:latin typeface="Helvetica Neue"/>
               </a:rPr>
-              <a:t>A ticket that deliberately carries a credential. The scanners find it, the run stops at the security stage, and nothing after it runs.</a:t>
+              <a:t>A real ticket: pin an old version of a library for a legacy system. Nothing is planted and no demo flag is set. Trivy finds a known vulnerability, the run stops at the security stage, and nothing after it runs.</a:t>
             </a:r>
           </a:p>
         </p:txBody>
@@ -13489,7 +13501,7 @@
                 </a:solidFill>
                 <a:latin typeface="Helvetica Neue"/>
               </a:rPr>
-              <a:t>Watch the line numbers: the real scanners report lines 3 and 4. The built-in stand-in, used only when a scanner is unavailable, reports 4 and 5, so the pair shows a real scan happened.</a:t>
+              <a:t>Watch the threshold: the high-severity finding stops the run, and the medium ones do not. The same comparison, per scanner, is on the screen.</a:t>
             </a:r>
           </a:p>
         </p:txBody>
@@ -17298,7 +17310,7 @@
                 </a:solidFill>
                 <a:latin typeface="Helvetica Neue"/>
               </a:rPr>
-              <a:t>a ticket that carries a credential, refused</a:t>
+              <a:t>a ticket that pins a vulnerable library, refused</a:t>
             </a:r>
           </a:p>
         </p:txBody>

</xml_diff>

<commit_message>
docs: retrieval switched on and verified on run #75; mirror the finals pitch at v56
Co-Authored-By: Claude Opus 5.5 <noreply@anthropic.com>
</commit_message>
<xml_diff>
--- a/docs/pitch/TheAgentOrg-hackathon-finals.pptx
+++ b/docs/pitch/TheAgentOrg-hackathon-finals.pptx
@@ -746,7 +746,7 @@
           <a:lstStyle/>
           <a:p>
             <a:r>
-              <a:t>SAY Two thousand one hundred and seventy-six automated tests across ninety-five files, plus three hundred and thirty-eight for the web app. Five agent runtimes, all ready on the same version; a split would mean a half-finished deploy, and we check for it before every demo. It runs in the cloud from a real issue. It is a product, not a script: you sign in, pick a repository, start a run, watch each stage, approve a gate and read what it cost. And it is multi-tenant: each customer's data sits in its own partition, and AWS itself refuses a read of anyone else's, so our code does not have to remember to.</a:t>
+              <a:t>SAY Two thousand one hundred and eighty-two automated tests across ninety-six files, plus three hundred and thirty-eight for the web app. Five agent runtimes, all ready on the same version; a split would mean a half-finished deploy, and we check for it before every demo. It runs in the cloud from a real issue. It is a product, not a script: you sign in, pick a repository, start a run, watch each stage, approve a gate and read what it cost. And it is multi-tenant: each customer's data sits in its own partition, and AWS itself refuses a read of anyone else's, so our code does not have to remember to.</a:t>
             </a:r>
           </a:p>
         </p:txBody>
@@ -817,6 +817,12 @@
           <a:p>
             <a:r>
               <a:t>SAY You gave us ten notes in the pre-final, and every row here is an answer that now exists. One in particular. You asked how the scanners' scores turn into a go or no-go, because you doubted the determinism claim, and you were right to. It held for Trivy and Semgrep, which report their own severities. For gitleaks the word "critical" was simply typed where each finding was created: no table, no policy. There is now one scoring table for all three scanners, and the rule for secrets is written down as a policy. Your note produced a real correction, and I would rather say so than claim we were right all along.</a:t>
+            </a:r>
+          </a:p>
+          <a:p/>
+          <a:p>
+            <a:r>
+              <a:t>IF ASKED — "is the knowledge base real?" Yes. Three hand-written knowledge bases: why past changes were sent back, the team's settled conventions, and security advisories. Before answering, four of the agents look up what is relevant, with plain keyword matching, no vector database. Measured: with it, the reviewer caught a change that did not match its ticket 8 times out of 8; without it, 6. It is switched on in the deployed system, and it never touches the security verdict.</a:t>
             </a:r>
           </a:p>
           <a:p/>
@@ -7335,7 +7341,7 @@
                 </a:solidFill>
                 <a:latin typeface="Helvetica Neue"/>
               </a:rPr>
-              <a:t>2176</a:t>
+              <a:t>2182</a:t>
             </a:r>
           </a:p>
         </p:txBody>
@@ -7390,7 +7396,7 @@
                 </a:solidFill>
                 <a:latin typeface="Helvetica Neue"/>
               </a:rPr>
-              <a:t>across 95 files</a:t>
+              <a:t>across 96 files</a:t>
             </a:r>
           </a:p>
         </p:txBody>
@@ -7523,7 +7529,7 @@
                 </a:solidFill>
                 <a:latin typeface="Helvetica Neue"/>
               </a:rPr>
-              <a:t>v55</a:t>
+              <a:t>v56</a:t>
             </a:r>
           </a:p>
         </p:txBody>

</xml_diff>